<commit_message>
Team: add M Praneeth Reddy (2320090018); spelling Boddupally Narendar
Updated current documents (final report, reproducibility report v2, Review-3
deck, enhancement proposal, Week-12 results, Week-3 worksheet spelling),
README, NOTICE and CLAUDE.md. Already-presented documents (Review-II deck,
Week-1 deck, report v1) are left as submitted; past weekly reports unchanged
pending the join date.

Co-Authored-By: Claude Opus 5.5 <noreply@anthropic.com>
</commit_message>
<xml_diff>
--- a/docs/reviews/Review3_QueryGenie.pptx
+++ b/docs/reviews/Review3_QueryGenie.pptx
@@ -4971,7 +4971,14 @@
             <a:pPr algn="r"/>
             <a:r>
               <a:rPr lang="en-US" dirty="0"/>
-              <a:t>2320090009 : Bodupally Narendar</a:t>
+              <a:t>2320090009 : Boddupally Narendar</a:t>
+            </a:r>
+          </a:p>
+          <a:p>
+            <a:pPr algn="r"/>
+            <a:r>
+              <a:rPr lang="en-US" dirty="0"/>
+              <a:t>2320090018 : M Praneeth Reddy</a:t>
             </a:r>
           </a:p>
           <a:p>

</xml_diff>